<commit_message>
Create (3.12) UI Scene 생성
</commit_message>
<xml_diff>
--- a/(3.12) ..pptx
+++ b/(3.12) ..pptx
@@ -6,6 +6,7 @@
   </p:sldMasterIdLst>
   <p:sldIdLst>
     <p:sldId id="257" r:id="rId2"/>
+    <p:sldId id="258" r:id="rId3"/>
   </p:sldIdLst>
   <p:sldSz cx="12192000" cy="6858000"/>
   <p:notesSz cx="6858000" cy="9144000"/>
@@ -104,6 +105,11 @@
       </a:defRPr>
     </a:lvl9pPr>
   </p:defaultTextStyle>
+  <p:extLst>
+    <p:ext uri="{EFAFB233-063F-42B5-8137-9DF3F51BA10A}">
+      <p15:sldGuideLst xmlns:p15="http://schemas.microsoft.com/office/powerpoint/2012/main"/>
+    </p:ext>
+  </p:extLst>
 </p:presentation>
 </file>
 
@@ -112,7 +118,7 @@
   <pc:docChgLst>
     <pc:chgData name="musukie52@gmail.com" userId="017bd91f96aa8751" providerId="LiveId" clId="{5B2C3894-F97E-4CAB-8812-5BB4D83AAC6A}"/>
     <pc:docChg chg="addSld delSld modSld">
-      <pc:chgData name="musukie52@gmail.com" userId="017bd91f96aa8751" providerId="LiveId" clId="{5B2C3894-F97E-4CAB-8812-5BB4D83AAC6A}" dt="2026-03-12T05:02:22.825" v="106" actId="20577"/>
+      <pc:chgData name="musukie52@gmail.com" userId="017bd91f96aa8751" providerId="LiveId" clId="{5B2C3894-F97E-4CAB-8812-5BB4D83AAC6A}" dt="2026-03-12T05:03:42.666" v="192" actId="20577"/>
       <pc:docMkLst>
         <pc:docMk/>
       </pc:docMkLst>
@@ -124,7 +130,7 @@
         </pc:sldMkLst>
       </pc:sldChg>
       <pc:sldChg chg="modSp new mod">
-        <pc:chgData name="musukie52@gmail.com" userId="017bd91f96aa8751" providerId="LiveId" clId="{5B2C3894-F97E-4CAB-8812-5BB4D83AAC6A}" dt="2026-03-12T05:02:22.825" v="106" actId="20577"/>
+        <pc:chgData name="musukie52@gmail.com" userId="017bd91f96aa8751" providerId="LiveId" clId="{5B2C3894-F97E-4CAB-8812-5BB4D83AAC6A}" dt="2026-03-12T05:03:42.666" v="192" actId="20577"/>
         <pc:sldMkLst>
           <pc:docMk/>
           <pc:sldMk cId="2848884687" sldId="257"/>
@@ -138,13 +144,20 @@
           </ac:spMkLst>
         </pc:spChg>
         <pc:spChg chg="mod">
-          <ac:chgData name="musukie52@gmail.com" userId="017bd91f96aa8751" providerId="LiveId" clId="{5B2C3894-F97E-4CAB-8812-5BB4D83AAC6A}" dt="2026-03-12T05:02:22.825" v="106" actId="20577"/>
+          <ac:chgData name="musukie52@gmail.com" userId="017bd91f96aa8751" providerId="LiveId" clId="{5B2C3894-F97E-4CAB-8812-5BB4D83AAC6A}" dt="2026-03-12T05:03:42.666" v="192" actId="20577"/>
           <ac:spMkLst>
             <pc:docMk/>
             <pc:sldMk cId="2848884687" sldId="257"/>
             <ac:spMk id="3" creationId="{952B1FA5-E270-2670-2536-C541CAC1D530}"/>
           </ac:spMkLst>
         </pc:spChg>
+      </pc:sldChg>
+      <pc:sldChg chg="new">
+        <pc:chgData name="musukie52@gmail.com" userId="017bd91f96aa8751" providerId="LiveId" clId="{5B2C3894-F97E-4CAB-8812-5BB4D83AAC6A}" dt="2026-03-12T05:03:25.230" v="107" actId="680"/>
+        <pc:sldMkLst>
+          <pc:docMk/>
+          <pc:sldMk cId="3197153169" sldId="258"/>
+        </pc:sldMkLst>
       </pc:sldChg>
     </pc:docChg>
   </pc:docChgLst>
@@ -3419,10 +3432,23 @@
               <a:t>기획자는 유니티 활용 기술에 대해서 따로 적어야 한다</a:t>
             </a:r>
             <a:r>
-              <a:rPr lang="en-US" altLang="ko-KR"/>
+              <a:rPr lang="en-US" altLang="ko-KR" dirty="0"/>
               <a:t>.</a:t>
             </a:r>
-            <a:endParaRPr lang="ko-KR" altLang="en-US"/>
+          </a:p>
+          <a:p>
+            <a:endParaRPr lang="en-US" altLang="ko-KR" dirty="0"/>
+          </a:p>
+          <a:p>
+            <a:r>
+              <a:rPr lang="ko-KR" altLang="en-US" dirty="0"/>
+              <a:t>아트 디자이너들은 포트폴리오에 활용해야 한다</a:t>
+            </a:r>
+            <a:r>
+              <a:rPr lang="en-US" altLang="ko-KR" dirty="0"/>
+              <a:t>.</a:t>
+            </a:r>
+            <a:endParaRPr lang="ko-KR" altLang="en-US" dirty="0"/>
           </a:p>
         </p:txBody>
       </p:sp>
@@ -3430,6 +3456,86 @@
     <p:extLst>
       <p:ext uri="{BB962C8B-B14F-4D97-AF65-F5344CB8AC3E}">
         <p14:creationId xmlns:p14="http://schemas.microsoft.com/office/powerpoint/2010/main" val="2848884687"/>
+      </p:ext>
+    </p:extLst>
+  </p:cSld>
+  <p:clrMapOvr>
+    <a:masterClrMapping/>
+  </p:clrMapOvr>
+</p:sld>
+</file>
+
+<file path=ppt/slides/slide2.xml><?xml version="1.0" encoding="utf-8"?>
+<p:sld xmlns:a="http://schemas.openxmlformats.org/drawingml/2006/main" xmlns:r="http://schemas.openxmlformats.org/officeDocument/2006/relationships" xmlns:p="http://schemas.openxmlformats.org/presentationml/2006/main">
+  <p:cSld>
+    <p:spTree>
+      <p:nvGrpSpPr>
+        <p:cNvPr id="1" name=""/>
+        <p:cNvGrpSpPr/>
+        <p:nvPr/>
+      </p:nvGrpSpPr>
+      <p:grpSpPr>
+        <a:xfrm>
+          <a:off x="0" y="0"/>
+          <a:ext cx="0" cy="0"/>
+          <a:chOff x="0" y="0"/>
+          <a:chExt cx="0" cy="0"/>
+        </a:xfrm>
+      </p:grpSpPr>
+      <p:sp>
+        <p:nvSpPr>
+          <p:cNvPr id="2" name="제목 1">
+            <a:extLst>
+              <a:ext uri="{FF2B5EF4-FFF2-40B4-BE49-F238E27FC236}">
+                <a16:creationId xmlns:a16="http://schemas.microsoft.com/office/drawing/2014/main" id="{B19D1D0C-C0EE-1273-B1B0-29E96FD5B62A}"/>
+              </a:ext>
+            </a:extLst>
+          </p:cNvPr>
+          <p:cNvSpPr>
+            <a:spLocks noGrp="1"/>
+          </p:cNvSpPr>
+          <p:nvPr>
+            <p:ph type="title"/>
+          </p:nvPr>
+        </p:nvSpPr>
+        <p:spPr/>
+        <p:txBody>
+          <a:bodyPr/>
+          <a:lstStyle/>
+          <a:p>
+            <a:endParaRPr lang="ko-KR" altLang="en-US"/>
+          </a:p>
+        </p:txBody>
+      </p:sp>
+      <p:sp>
+        <p:nvSpPr>
+          <p:cNvPr id="3" name="내용 개체 틀 2">
+            <a:extLst>
+              <a:ext uri="{FF2B5EF4-FFF2-40B4-BE49-F238E27FC236}">
+                <a16:creationId xmlns:a16="http://schemas.microsoft.com/office/drawing/2014/main" id="{A79A4AC9-398B-8FE4-6DFB-987516F186E3}"/>
+              </a:ext>
+            </a:extLst>
+          </p:cNvPr>
+          <p:cNvSpPr>
+            <a:spLocks noGrp="1"/>
+          </p:cNvSpPr>
+          <p:nvPr>
+            <p:ph idx="1"/>
+          </p:nvPr>
+        </p:nvSpPr>
+        <p:spPr/>
+        <p:txBody>
+          <a:bodyPr/>
+          <a:lstStyle/>
+          <a:p>
+            <a:endParaRPr lang="ko-KR" altLang="en-US"/>
+          </a:p>
+        </p:txBody>
+      </p:sp>
+    </p:spTree>
+    <p:extLst>
+      <p:ext uri="{BB962C8B-B14F-4D97-AF65-F5344CB8AC3E}">
+        <p14:creationId xmlns:p14="http://schemas.microsoft.com/office/powerpoint/2010/main" val="3197153169"/>
       </p:ext>
     </p:extLst>
   </p:cSld>

</xml_diff>